<commit_message>
랩미팅 PPT 용어 업데이트: Spectral Gaussian→spectral, Pre-registered→Pre-specified
Co-Authored-By: Claude Opus 4.6 <noreply@anthropic.com>
</commit_message>
<xml_diff>
--- a/wavesplat/docs/labmeeting_wavesplat.pptx
+++ b/wavesplat/docs/labmeeting_wavesplat.pptx
@@ -20,8 +20,6 @@
     <p:sldId id="268" r:id="rId19"/>
     <p:sldId id="269" r:id="rId20"/>
     <p:sldId id="270" r:id="rId21"/>
-    <p:sldId id="272" r:id="rId23"/>
-    <p:sldId id="273" r:id="rId24"/>
     <p:sldId id="271" r:id="rId22"/>
   </p:sldIdLst>
   <p:sldSz cx="12191695" cy="6858000" type="screen4x3"/>
@@ -3180,7 +3178,7 @@
               </a:defRPr>
             </a:pPr>
             <a:r>
-              <a:t>Grid-Free Spectral Gaussian Wave Field Estimation</a:t>
+              <a:t>Grid-Free Spectral Wave Field Estimation</a:t>
             </a:r>
             <a:br/>
             <a:r>
@@ -6456,7 +6454,7 @@
                 </a:solidFill>
                 <a:latin typeface="Calibri"/>
               </a:rPr>
-              <a:t>• • ❶ Grid-free spectral Gaussian 파면 추정</a:t>
+              <a:t>• • ❶ Grid-free spectral 파면 추정</a:t>
             </a:r>
           </a:p>
           <a:p>
@@ -6520,7 +6518,7 @@
                 </a:solidFill>
                 <a:latin typeface="Calibri"/>
               </a:rPr>
-              <a:t>• • ❺ Pre-registered 6-metric panel</a:t>
+              <a:t>• • ❺ Pre-specified 6-metric panel</a:t>
             </a:r>
           </a:p>
           <a:p>
@@ -7378,322 +7376,6 @@
             </a:pPr>
             <a:r>
               <a:t>16/16</a:t>
-            </a:r>
-          </a:p>
-        </p:txBody>
-      </p:sp>
-    </p:spTree>
-  </p:cSld>
-  <p:clrMapOvr>
-    <a:masterClrMapping/>
-  </p:clrMapOvr>
-</p:sld>
-</file>
-
-<file path=ppt/slides/slide17.xml><?xml version="1.0" encoding="utf-8"?>
-<p:sld xmlns:a="http://schemas.openxmlformats.org/drawingml/2006/main" xmlns:p="http://schemas.openxmlformats.org/presentationml/2006/main" xmlns:r="http://schemas.openxmlformats.org/officeDocument/2006/relationships">
-  <p:cSld>
-    <p:spTree>
-      <p:nvGrpSpPr>
-        <p:cNvPr id="1" name=""/>
-        <p:cNvGrpSpPr/>
-        <p:nvPr/>
-      </p:nvGrpSpPr>
-      <p:grpSpPr/>
-      <p:sp>
-        <p:nvSpPr>
-          <p:cNvPr id="2" name="Title 1"/>
-          <p:cNvSpPr>
-            <a:spLocks noGrp="1"/>
-          </p:cNvSpPr>
-          <p:nvPr>
-            <p:ph type="title"/>
-          </p:nvPr>
-        </p:nvSpPr>
-        <p:spPr/>
-        <p:txBody>
-          <a:bodyPr/>
-          <a:lstStyle/>
-          <a:p/>
-        </p:txBody>
-      </p:sp>
-      <p:sp>
-        <p:nvSpPr>
-          <p:cNvPr id="3" name="TextBox 2"/>
-          <p:cNvSpPr txBox="1"/>
-          <p:nvPr/>
-        </p:nvSpPr>
-        <p:spPr>
-          <a:xfrm>
-            <a:off x="457200" y="182880"/>
-            <a:ext cx="8229600" cy="731520"/>
-          </a:xfrm>
-          <a:prstGeom prst="rect">
-            <a:avLst/>
-          </a:prstGeom>
-          <a:noFill/>
-        </p:spPr>
-        <p:txBody>
-          <a:bodyPr wrap="none">
-            <a:spAutoFit/>
-          </a:bodyPr>
-          <a:lstStyle/>
-          <a:p>
-            <a:pPr>
-              <a:defRPr sz="2400" b="1"/>
-            </a:pPr>
-            <a:r>
-              <a:t>τ_R Sensitivity — Residual Growth Threshold</a:t>
-            </a:r>
-          </a:p>
-        </p:txBody>
-      </p:sp>
-      <p:pic>
-        <p:nvPicPr>
-          <p:cNvPr id="4" name="Picture 3" descr="fig_tau_sensitivity.png"/>
-          <p:cNvPicPr>
-            <a:picLocks noChangeAspect="1"/>
-          </p:cNvPicPr>
-          <p:nvPr/>
-        </p:nvPicPr>
-        <p:blipFill>
-          <a:blip r:embed="rId2"/>
-          <a:stretch>
-            <a:fillRect/>
-          </a:stretch>
-        </p:blipFill>
-        <p:spPr>
-          <a:xfrm>
-            <a:off x="731520" y="1097280"/>
-            <a:ext cx="7315200" cy="3657600"/>
-          </a:xfrm>
-          <a:prstGeom prst="rect">
-            <a:avLst/>
-          </a:prstGeom>
-        </p:spPr>
-      </p:pic>
-      <p:sp>
-        <p:nvSpPr>
-          <p:cNvPr id="5" name="TextBox 4"/>
-          <p:cNvSpPr txBox="1"/>
-          <p:nvPr/>
-        </p:nvSpPr>
-        <p:spPr>
-          <a:xfrm>
-            <a:off x="457200" y="5029200"/>
-            <a:ext cx="8229600" cy="1371600"/>
-          </a:xfrm>
-          <a:prstGeom prst="rect">
-            <a:avLst/>
-          </a:prstGeom>
-          <a:noFill/>
-        </p:spPr>
-        <p:txBody>
-          <a:bodyPr wrap="none">
-            <a:spAutoFit/>
-          </a:bodyPr>
-          <a:lstStyle/>
-          <a:p>
-            <a:pPr>
-              <a:defRPr sz="1400"/>
-            </a:pPr>
-            <a:r>
-              <a:t>• τ_R=0.05m이 최적 (avg nRMSE 0.2114)</a:t>
-            </a:r>
-          </a:p>
-          <a:p>
-            <a:pPr>
-              <a:defRPr sz="1400"/>
-            </a:pPr>
-            <a:r>
-              <a:t>• [0.05, 0.15]m 범위에서 차이 최대 1.6% → robust</a:t>
-            </a:r>
-          </a:p>
-          <a:p>
-            <a:pPr>
-              <a:defRPr sz="1400"/>
-            </a:pPr>
-            <a:r>
-              <a:t>• τ_R=0.02m: 과성장 (+3.3%, BF3 2comp에서 최대 75% 악화)</a:t>
-            </a:r>
-          </a:p>
-        </p:txBody>
-      </p:sp>
-    </p:spTree>
-  </p:cSld>
-  <p:clrMapOvr>
-    <a:masterClrMapping/>
-  </p:clrMapOvr>
-</p:sld>
-</file>
-
-<file path=ppt/slides/slide18.xml><?xml version="1.0" encoding="utf-8"?>
-<p:sld xmlns:a="http://schemas.openxmlformats.org/drawingml/2006/main" xmlns:p="http://schemas.openxmlformats.org/presentationml/2006/main" xmlns:r="http://schemas.openxmlformats.org/officeDocument/2006/relationships">
-  <p:cSld>
-    <p:spTree>
-      <p:nvGrpSpPr>
-        <p:cNvPr id="1" name=""/>
-        <p:cNvGrpSpPr/>
-        <p:nvPr/>
-      </p:nvGrpSpPr>
-      <p:grpSpPr/>
-      <p:sp>
-        <p:nvSpPr>
-          <p:cNvPr id="2" name="Title 1"/>
-          <p:cNvSpPr>
-            <a:spLocks noGrp="1"/>
-          </p:cNvSpPr>
-          <p:nvPr>
-            <p:ph type="title"/>
-          </p:nvPr>
-        </p:nvSpPr>
-        <p:spPr/>
-        <p:txBody>
-          <a:bodyPr/>
-          <a:lstStyle/>
-          <a:p/>
-        </p:txBody>
-      </p:sp>
-      <p:sp>
-        <p:nvSpPr>
-          <p:cNvPr id="3" name="TextBox 2"/>
-          <p:cNvSpPr txBox="1"/>
-          <p:nvPr/>
-        </p:nvSpPr>
-        <p:spPr>
-          <a:xfrm>
-            <a:off x="457200" y="182880"/>
-            <a:ext cx="8229600" cy="731520"/>
-          </a:xfrm>
-          <a:prstGeom prst="rect">
-            <a:avLst/>
-          </a:prstGeom>
-          <a:noFill/>
-        </p:spPr>
-        <p:txBody>
-          <a:bodyPr wrap="none">
-            <a:spAutoFit/>
-          </a:bodyPr>
-          <a:lstStyle/>
-          <a:p>
-            <a:pPr>
-              <a:defRPr sz="2400" b="1"/>
-            </a:pPr>
-            <a:r>
-              <a:t>GPR + Confidence Ablation — C3 Novelty 검증</a:t>
-            </a:r>
-          </a:p>
-        </p:txBody>
-      </p:sp>
-      <p:sp>
-        <p:nvSpPr>
-          <p:cNvPr id="4" name="TextBox 3"/>
-          <p:cNvSpPr txBox="1"/>
-          <p:nvPr/>
-        </p:nvSpPr>
-        <p:spPr>
-          <a:xfrm>
-            <a:off x="457200" y="1097280"/>
-            <a:ext cx="8229600" cy="4572000"/>
-          </a:xfrm>
-          <a:prstGeom prst="rect">
-            <a:avLst/>
-          </a:prstGeom>
-          <a:noFill/>
-        </p:spPr>
-        <p:txBody>
-          <a:bodyPr wrap="none">
-            <a:spAutoFit/>
-          </a:bodyPr>
-          <a:lstStyle/>
-          <a:p>
-            <a:pPr>
-              <a:defRPr sz="1600" b="1"/>
-            </a:pPr>
-            <a:r>
-              <a:t>질문: Confidence weighting은 WaveSplat 고유 효과인가, 범용 기법인가?</a:t>
-            </a:r>
-          </a:p>
-          <a:p>
-            <a:pPr>
-              <a:defRPr sz="1400"/>
-            </a:pPr>
-          </a:p>
-          <a:p>
-            <a:pPr>
-              <a:defRPr sz="1400"/>
-            </a:pPr>
-            <a:r>
-              <a:t>4-way 비교 (10 uniform episodes):</a:t>
-            </a:r>
-          </a:p>
-          <a:p>
-            <a:pPr>
-              <a:defRPr sz="1400"/>
-            </a:pPr>
-            <a:r>
-              <a:t>  • WaveSplat + confidence:    0.2325</a:t>
-            </a:r>
-          </a:p>
-          <a:p>
-            <a:pPr>
-              <a:defRPr sz="1400"/>
-            </a:pPr>
-            <a:r>
-              <a:t>  • WaveSplat − confidence:    0.2308  (−0.7%)</a:t>
-            </a:r>
-          </a:p>
-          <a:p>
-            <a:pPr>
-              <a:defRPr sz="1400"/>
-            </a:pPr>
-            <a:r>
-              <a:t>  • GPR (표준):                         0.2756</a:t>
-            </a:r>
-          </a:p>
-          <a:p>
-            <a:pPr>
-              <a:defRPr sz="1400"/>
-            </a:pPr>
-            <a:r>
-              <a:t>  • GPR + confidence:              0.2757  (&lt;0.01% 차이!)</a:t>
-            </a:r>
-          </a:p>
-          <a:p>
-            <a:pPr>
-              <a:defRPr sz="1400"/>
-            </a:pPr>
-          </a:p>
-          <a:p>
-            <a:pPr>
-              <a:defRPr sz="1400"/>
-            </a:pPr>
-            <a:r>
-              <a:t>결론:</a:t>
-            </a:r>
-          </a:p>
-          <a:p>
-            <a:pPr>
-              <a:defRPr sz="1400"/>
-            </a:pPr>
-            <a:r>
-              <a:t>  → GPR에 confidence 적용해도 효과 없음 (&lt;0.01%)</a:t>
-            </a:r>
-          </a:p>
-          <a:p>
-            <a:pPr>
-              <a:defRPr sz="1400"/>
-            </a:pPr>
-            <a:r>
-              <a:t>  → Confidence의 14.5% 효과는 spectral parameterization과의 상호작용</a:t>
-            </a:r>
-          </a:p>
-          <a:p>
-            <a:pPr>
-              <a:defRPr sz="1400"/>
-            </a:pPr>
-            <a:r>
-              <a:t>  → C3 (Fresnel confidence) novelty 유효</a:t>
             </a:r>
           </a:p>
         </p:txBody>
@@ -9134,7 +8816,7 @@
               </a:defRPr>
             </a:pPr>
             <a:r>
-              <a:t>핵심 아이디어: 파도장을 N개의 spectral Gaussian (plane wave)으로 직접 파라미터화</a:t>
+              <a:t>핵심 아이디어: 파도장을 N개의 spectral component (plane wave)로 직접 파라미터화</a:t>
             </a:r>
           </a:p>
         </p:txBody>
@@ -9273,7 +8955,7 @@
                 </a:solidFill>
                 <a:latin typeface="Calibri"/>
               </a:rPr>
-              <a:t>• • ❺ Pre-registered 6-metric evaluation panel — zero-predictor 구분 가능</a:t>
+              <a:t>• • ❺ Pre-specified 6-metric evaluation panel — zero-predictor 구분 가능</a:t>
             </a:r>
           </a:p>
           <a:p>
@@ -10045,7 +9727,7 @@
                 </a:solidFill>
                 <a:latin typeface="Calibri"/>
               </a:rPr>
-              <a:t>• •    → Cartesian k-grid (81×81, ±4.0 rad/m)</a:t>
+              <a:t>• •    → polar k-grid (64 radial × 128 azimuthal)</a:t>
             </a:r>
           </a:p>
           <a:p>
@@ -10061,7 +9743,7 @@
                 </a:solidFill>
                 <a:latin typeface="Calibri"/>
               </a:rPr>
-              <a:t>• • ② Greedy peak extraction (0.15 rad/m suppression)</a:t>
+              <a:t>• • ② Greedy peak extraction (15° suppression)</a:t>
             </a:r>
           </a:p>
           <a:p>
@@ -12237,7 +11919,7 @@
               </a:defRPr>
             </a:pPr>
             <a:r>
-              <a:t>Pre-registered 6-metric evaluation panel</a:t>
+              <a:t>Pre-specified 6-metric evaluation panel</a:t>
             </a:r>
           </a:p>
         </p:txBody>

</xml_diff>

<commit_message>
PPT 재생성 + LaTeX 빌드 산출물 gitignore 추가
- labmeeting_wavesplat.pptx 재생성 (Slide 6 수정 반영)
- .gitignore에 *.spl, *.lof, *.lot, *.toc, wavesplat.pdf 추가

Co-Authored-By: Claude Opus 4.6 <noreply@anthropic.com>
</commit_message>
<xml_diff>
--- a/wavesplat/docs/labmeeting_wavesplat.pptx
+++ b/wavesplat/docs/labmeeting_wavesplat.pptx
@@ -14583,7 +14583,7 @@
                 </a:solidFill>
                 <a:latin typeface="Calibri"/>
               </a:rPr>
-              <a:t>• •    → polar k-grid (64 radial × 128 azimuthal)</a:t>
+              <a:t>• •    → Cartesian 81×81 k-grid (Δk≈0.10 rad/m)</a:t>
             </a:r>
           </a:p>
           <a:p>
@@ -14599,7 +14599,7 @@
                 </a:solidFill>
                 <a:latin typeface="Calibri"/>
               </a:rPr>
-              <a:t>• • ② Greedy peak extraction (15° suppression)</a:t>
+              <a:t>• • ② Greedy peak extraction (0.15 rad/m suppression)</a:t>
             </a:r>
           </a:p>
           <a:p>

</xml_diff>

<commit_message>
PPT v2.1: Controller flowchart 겹침 수정 + 여백 많은 5장 밀도 보강
수정/보강:
- Slide 24 Controller Flowchart: Foil Servo와 Feedforward Gain 박스 겹침 해결
  → Foil Servo를 우측 끝(x=11.4)으로 이동, 양 row spanning 명확,
    sum 라벨 추가, 14×5.5 인치 캔버스로 재생성
- Slide 17 Ablation: 'Forecast 능력 차이' (5초 외삽 비교) +
  '왜 dispersion drift R̄=0.51이면 위험?' (한 component 구체 예시) 추가
- Slide 19 Qualitative: 그림 placeholder 높이 축소(2.80 in),
  'Per-method 정성 진단' 섹션 + 시각적 한 줄 결론 추가
- Slide 21 추가 기여 (2): 'Forecast skill score (paper Table)' 5개 BF×N 조합
  구체 수치 (BF3 1c +0.96 ~ BF4 15c −0.21) + 위치 정리
- Slide 25 Hydrofoil 결과 (1): 'ISO 2631 승차감 기준' 분류표 +
  'Encounter angle별 해석' (Head/Beam/Quarter/Following) 추가
- Slide 27 Hydrofoil E2E: 'BF4 한계의 원인 — Direction error 전파' 단락
  (수식 + 예시) + 개선 방향 banner 추가

Co-Authored-By: Claude Opus 4.7 (1M context) <noreply@anthropic.com>
</commit_message>
<xml_diff>
--- a/wavesplat/docs/labmeeting_wavesplat.pptx
+++ b/wavesplat/docs/labmeeting_wavesplat.pptx
@@ -8026,6 +8026,230 @@
           </a:p>
         </p:txBody>
       </p:sp>
+      <p:sp>
+        <p:nvSpPr>
+          <p:cNvPr id="8" name="TextBox 7"/>
+          <p:cNvSpPr txBox="1"/>
+          <p:nvPr/>
+        </p:nvSpPr>
+        <p:spPr>
+          <a:xfrm>
+            <a:off x="365760" y="5166360"/>
+            <a:ext cx="4114800" cy="274320"/>
+          </a:xfrm>
+          <a:prstGeom prst="rect">
+            <a:avLst/>
+          </a:prstGeom>
+          <a:noFill/>
+        </p:spPr>
+        <p:txBody>
+          <a:bodyPr wrap="none">
+            <a:spAutoFit/>
+          </a:bodyPr>
+          <a:lstStyle/>
+          <a:p>
+            <a:r>
+              <a:rPr sz="1200" b="1">
+                <a:solidFill>
+                  <a:srgbClr val="C05317"/>
+                </a:solidFill>
+                <a:latin typeface="Times New Roman"/>
+              </a:rPr>
+              <a:t>추가 분석 — Forecast 능력 차이</a:t>
+            </a:r>
+          </a:p>
+        </p:txBody>
+      </p:sp>
+      <p:sp>
+        <p:nvSpPr>
+          <p:cNvPr id="9" name="TextBox 8"/>
+          <p:cNvSpPr txBox="1"/>
+          <p:nvPr/>
+        </p:nvSpPr>
+        <p:spPr>
+          <a:xfrm>
+            <a:off x="365760" y="5486400"/>
+            <a:ext cx="4114800" cy="1097280"/>
+          </a:xfrm>
+          <a:prstGeom prst="rect">
+            <a:avLst/>
+          </a:prstGeom>
+          <a:noFill/>
+        </p:spPr>
+        <p:txBody>
+          <a:bodyPr wrap="square">
+            <a:spAutoFit/>
+          </a:bodyPr>
+          <a:lstStyle/>
+          <a:p>
+            <a:r>
+              <a:rPr sz="1100" b="1" i="0">
+                <a:solidFill>
+                  <a:srgbClr val="1A1A2E"/>
+                </a:solidFill>
+                <a:latin typeface="Times New Roman"/>
+              </a:rPr>
+              <a:t>A1 (no dispersion) — 외삽 5초 후 비교</a:t>
+            </a:r>
+          </a:p>
+          <a:p>
+            <a:r>
+              <a:rPr sz="1000" b="0" i="0">
+                <a:solidFill>
+                  <a:srgbClr val="333333"/>
+                </a:solidFill>
+                <a:latin typeface="Times New Roman"/>
+              </a:rPr>
+              <a:t>▪ Full: nRMSE 0.219 → 5초 후 0.231 (4% 증가)</a:t>
+            </a:r>
+          </a:p>
+          <a:p>
+            <a:r>
+              <a:rPr sz="1000" b="0" i="0">
+                <a:solidFill>
+                  <a:srgbClr val="333333"/>
+                </a:solidFill>
+                <a:latin typeface="Times New Roman"/>
+              </a:rPr>
+              <a:t>▪ A1:   nRMSE 0.158 → 5초 후 0.476 (3× 폭발)</a:t>
+            </a:r>
+          </a:p>
+          <a:p>
+            <a:r>
+              <a:rPr sz="1000" b="0" i="0">
+                <a:solidFill>
+                  <a:srgbClr val="333333"/>
+                </a:solidFill>
+                <a:latin typeface="Times New Roman"/>
+              </a:rPr>
+              <a:t>▪ A1은 instantaneous는 좋지만 시간 외삽 직후</a:t>
+            </a:r>
+          </a:p>
+          <a:p>
+            <a:r>
+              <a:rPr sz="1000" b="0" i="0">
+                <a:solidFill>
+                  <a:srgbClr val="333333"/>
+                </a:solidFill>
+                <a:latin typeface="Times New Roman"/>
+              </a:rPr>
+              <a:t>   phase decoherence로 사용 불가</a:t>
+            </a:r>
+          </a:p>
+        </p:txBody>
+      </p:sp>
+      <p:sp>
+        <p:nvSpPr>
+          <p:cNvPr id="10" name="TextBox 9"/>
+          <p:cNvSpPr txBox="1"/>
+          <p:nvPr/>
+        </p:nvSpPr>
+        <p:spPr>
+          <a:xfrm>
+            <a:off x="4663440" y="5166360"/>
+            <a:ext cx="3931920" cy="274320"/>
+          </a:xfrm>
+          <a:prstGeom prst="rect">
+            <a:avLst/>
+          </a:prstGeom>
+          <a:noFill/>
+        </p:spPr>
+        <p:txBody>
+          <a:bodyPr wrap="none">
+            <a:spAutoFit/>
+          </a:bodyPr>
+          <a:lstStyle/>
+          <a:p>
+            <a:r>
+              <a:rPr sz="1200" b="1">
+                <a:solidFill>
+                  <a:srgbClr val="C05317"/>
+                </a:solidFill>
+                <a:latin typeface="Times New Roman"/>
+              </a:rPr>
+              <a:t>왜 dispersion drift R̄가 0.51이면 위험?</a:t>
+            </a:r>
+          </a:p>
+        </p:txBody>
+      </p:sp>
+      <p:sp>
+        <p:nvSpPr>
+          <p:cNvPr id="11" name="TextBox 10"/>
+          <p:cNvSpPr txBox="1"/>
+          <p:nvPr/>
+        </p:nvSpPr>
+        <p:spPr>
+          <a:xfrm>
+            <a:off x="4663440" y="5486400"/>
+            <a:ext cx="3931920" cy="1097280"/>
+          </a:xfrm>
+          <a:prstGeom prst="rect">
+            <a:avLst/>
+          </a:prstGeom>
+          <a:noFill/>
+        </p:spPr>
+        <p:txBody>
+          <a:bodyPr wrap="square">
+            <a:spAutoFit/>
+          </a:bodyPr>
+          <a:lstStyle/>
+          <a:p>
+            <a:r>
+              <a:rPr sz="1100" b="1" i="0">
+                <a:solidFill>
+                  <a:srgbClr val="1A1A2E"/>
+                </a:solidFill>
+                <a:latin typeface="Times New Roman"/>
+              </a:rPr>
+              <a:t>한 component 예시 (BF4 5c 첫 component)</a:t>
+            </a:r>
+          </a:p>
+          <a:p>
+            <a:r>
+              <a:rPr sz="1000" b="0" i="0">
+                <a:solidFill>
+                  <a:srgbClr val="333333"/>
+                </a:solidFill>
+                <a:latin typeface="Times New Roman"/>
+              </a:rPr>
+              <a:t>▪ |k|=0.16 rad/m  →  ω_disp = 1.25 rad/s</a:t>
+            </a:r>
+          </a:p>
+          <a:p>
+            <a:r>
+              <a:rPr sz="1000" b="0" i="0">
+                <a:solidFill>
+                  <a:srgbClr val="333333"/>
+                </a:solidFill>
+                <a:latin typeface="Times New Roman"/>
+              </a:rPr>
+              <a:t>▪ A1 추정 ω = 1.78 rad/s  →  Δω = 0.53 rad/s</a:t>
+            </a:r>
+          </a:p>
+          <a:p>
+            <a:r>
+              <a:rPr sz="1000" b="0" i="0">
+                <a:solidFill>
+                  <a:srgbClr val="333333"/>
+                </a:solidFill>
+                <a:latin typeface="Times New Roman"/>
+              </a:rPr>
+              <a:t>▪ 1초 후 phase 오차 ≈ 0.53 rad ≈ 30°</a:t>
+            </a:r>
+          </a:p>
+          <a:p>
+            <a:r>
+              <a:rPr sz="1000" b="0" i="0">
+                <a:solidFill>
+                  <a:srgbClr val="333333"/>
+                </a:solidFill>
+                <a:latin typeface="Times New Roman"/>
+              </a:rPr>
+              <a:t>▪ → 거의 모든 wave에서 위치 어긋남</a:t>
+            </a:r>
+          </a:p>
+        </p:txBody>
+      </p:sp>
     </p:spTree>
   </p:cSld>
   <p:clrMapOvr>
@@ -8758,7 +8982,7 @@
         <p:spPr>
           <a:xfrm>
             <a:off x="365760" y="868680"/>
-            <a:ext cx="8229600" cy="3200400"/>
+            <a:ext cx="8229600" cy="2560320"/>
           </a:xfrm>
           <a:prstGeom prst="rect">
             <a:avLst/>
@@ -8813,7 +9037,7 @@
         </p:nvSpPr>
         <p:spPr>
           <a:xfrm>
-            <a:off x="365760" y="4251960"/>
+            <a:off x="365760" y="3840480"/>
             <a:ext cx="8229600" cy="1828800"/>
           </a:xfrm>
           <a:prstGeom prst="rect">
@@ -8901,6 +9125,107 @@
                 <a:latin typeface="Times New Roman"/>
               </a:rPr>
               <a:t>※ 본 슬라이드는 paper Fig 8을 활용. 실 발표 시 demo_wavesplat.gif (animation) 같이 재생 가능</a:t>
+            </a:r>
+          </a:p>
+        </p:txBody>
+      </p:sp>
+      <p:sp>
+        <p:nvSpPr>
+          <p:cNvPr id="6" name="TextBox 5"/>
+          <p:cNvSpPr txBox="1"/>
+          <p:nvPr/>
+        </p:nvSpPr>
+        <p:spPr>
+          <a:xfrm>
+            <a:off x="365760" y="5532120"/>
+            <a:ext cx="8229600" cy="274320"/>
+          </a:xfrm>
+          <a:prstGeom prst="rect">
+            <a:avLst/>
+          </a:prstGeom>
+          <a:noFill/>
+        </p:spPr>
+        <p:txBody>
+          <a:bodyPr wrap="none">
+            <a:spAutoFit/>
+          </a:bodyPr>
+          <a:lstStyle/>
+          <a:p>
+            <a:r>
+              <a:rPr sz="1200" b="1">
+                <a:solidFill>
+                  <a:srgbClr val="C05317"/>
+                </a:solidFill>
+                <a:latin typeface="Times New Roman"/>
+              </a:rPr>
+              <a:t>Per-method 정성 진단</a:t>
+            </a:r>
+          </a:p>
+        </p:txBody>
+      </p:sp>
+      <p:sp>
+        <p:nvSpPr>
+          <p:cNvPr id="7" name="TextBox 6"/>
+          <p:cNvSpPr txBox="1"/>
+          <p:nvPr/>
+        </p:nvSpPr>
+        <p:spPr>
+          <a:xfrm>
+            <a:off x="365760" y="5852160"/>
+            <a:ext cx="8229600" cy="548640"/>
+          </a:xfrm>
+          <a:prstGeom prst="rect">
+            <a:avLst/>
+          </a:prstGeom>
+          <a:noFill/>
+        </p:spPr>
+        <p:txBody>
+          <a:bodyPr wrap="square">
+            <a:spAutoFit/>
+          </a:bodyPr>
+          <a:lstStyle/>
+          <a:p>
+            <a:r>
+              <a:rPr sz="1100" b="0" i="0">
+                <a:solidFill>
+                  <a:srgbClr val="333333"/>
+                </a:solidFill>
+                <a:latin typeface="Times New Roman"/>
+              </a:rPr>
+              <a:t>▪ WaveSplat: 파봉·파골 모두 GT의 80~90% 진폭 유지, 위상 거의 일치</a:t>
+            </a:r>
+          </a:p>
+          <a:p>
+            <a:r>
+              <a:rPr sz="1100" b="0" i="0">
+                <a:solidFill>
+                  <a:srgbClr val="333333"/>
+                </a:solidFill>
+                <a:latin typeface="Times New Roman"/>
+              </a:rPr>
+              <a:t>▪ ETKF: 진폭은 보존되지만 spatial structure가 noisy — 여러 spurious component에 에너지 분산</a:t>
+            </a:r>
+          </a:p>
+          <a:p>
+            <a:r>
+              <a:rPr sz="1100" b="0" i="0">
+                <a:solidFill>
+                  <a:srgbClr val="333333"/>
+                </a:solidFill>
+                <a:latin typeface="Times New Roman"/>
+              </a:rPr>
+              <a:t>▪ GPR: 표면이 거의 평탄 — VR=0.065와 일관 (zero-predictor에 가까움), 격자/커널 limit</a:t>
+            </a:r>
+          </a:p>
+          <a:p>
+            <a:r>
+              <a:rPr sz="1200" b="1" i="0">
+                <a:solidFill>
+                  <a:srgbClr val="C05317"/>
+                </a:solidFill>
+                <a:latin typeface="Times New Roman"/>
+              </a:rPr>
+              <a:t>시각적 한 줄 결론: WaveSplat만 "진짜 wave field 같은" 결과</a:t>
             </a:r>
           </a:p>
         </p:txBody>
@@ -10112,14 +10437,14 @@
       </p:sp>
       <p:sp>
         <p:nvSpPr>
-          <p:cNvPr id="8" name="TextBox 7"/>
+          <p:cNvPr id="9" name="TextBox 8"/>
           <p:cNvSpPr txBox="1"/>
           <p:nvPr/>
         </p:nvSpPr>
         <p:spPr>
           <a:xfrm>
-            <a:off x="365760" y="5669280"/>
-            <a:ext cx="8229600" cy="457200"/>
+            <a:off x="365760" y="4526280"/>
+            <a:ext cx="8229600" cy="274320"/>
           </a:xfrm>
           <a:prstGeom prst="rect">
             <a:avLst/>
@@ -10127,15 +10452,147 @@
           <a:noFill/>
         </p:spPr>
         <p:txBody>
+          <a:bodyPr wrap="none">
+            <a:spAutoFit/>
+          </a:bodyPr>
+          <a:lstStyle/>
+          <a:p>
+            <a:r>
+              <a:rPr sz="1200" b="1">
+                <a:solidFill>
+                  <a:srgbClr val="C05317"/>
+                </a:solidFill>
+                <a:latin typeface="Times New Roman"/>
+              </a:rPr>
+              <a:t>구체 결과 — Forecast skill score (paper Table)</a:t>
+            </a:r>
+          </a:p>
+        </p:txBody>
+      </p:sp>
+      <p:sp>
+        <p:nvSpPr>
+          <p:cNvPr id="10" name="TextBox 9"/>
+          <p:cNvSpPr txBox="1"/>
+          <p:nvPr/>
+        </p:nvSpPr>
+        <p:spPr>
+          <a:xfrm>
+            <a:off x="365760" y="4846320"/>
+            <a:ext cx="8229600" cy="1463040"/>
+          </a:xfrm>
+          <a:prstGeom prst="rect">
+            <a:avLst/>
+          </a:prstGeom>
+          <a:noFill/>
+        </p:spPr>
+        <p:txBody>
           <a:bodyPr wrap="square">
             <a:spAutoFit/>
           </a:bodyPr>
           <a:lstStyle/>
           <a:p>
             <a:r>
-              <a:rPr sz="1200" b="1" i="0">
-                <a:solidFill>
-                  <a:srgbClr val="C05317"/>
+              <a:rPr sz="1100" b="0" i="0">
+                <a:solidFill>
+                  <a:srgbClr val="333333"/>
+                </a:solidFill>
+                <a:latin typeface="Times New Roman"/>
+              </a:rPr>
+              <a:t>▪ BF3 1c   t+5s: SS = +0.96       t+10s: SS = +0.94</a:t>
+            </a:r>
+          </a:p>
+          <a:p>
+            <a:r>
+              <a:rPr sz="1100" b="0" i="0">
+                <a:solidFill>
+                  <a:srgbClr val="333333"/>
+                </a:solidFill>
+                <a:latin typeface="Times New Roman"/>
+              </a:rPr>
+              <a:t>▪ BF3 2c   t+5s: SS = +0.96       t+10s: SS = +0.95</a:t>
+            </a:r>
+          </a:p>
+          <a:p>
+            <a:r>
+              <a:rPr sz="1100" b="0" i="0">
+                <a:solidFill>
+                  <a:srgbClr val="333333"/>
+                </a:solidFill>
+                <a:latin typeface="Times New Roman"/>
+              </a:rPr>
+              <a:t>▪ BF3 5c   t+5s: SS = +0.41       t+10s: SS = +0.18  (multi-component → drift 누적)</a:t>
+            </a:r>
+          </a:p>
+          <a:p>
+            <a:r>
+              <a:rPr sz="1100" b="0" i="0">
+                <a:solidFill>
+                  <a:srgbClr val="333333"/>
+                </a:solidFill>
+                <a:latin typeface="Times New Roman"/>
+              </a:rPr>
+              <a:t>▪ BF4 5c   t+5s: SS = +0.36       t+10s: SS = +0.12</a:t>
+            </a:r>
+          </a:p>
+          <a:p>
+            <a:r>
+              <a:rPr sz="1100" b="0" i="0">
+                <a:solidFill>
+                  <a:srgbClr val="333333"/>
+                </a:solidFill>
+                <a:latin typeface="Times New Roman"/>
+              </a:rPr>
+              <a:t>▪ BF4 15c  t+5s: SS = −0.04       t+10s: SS = −0.21  (성분 수 한계)</a:t>
+            </a:r>
+          </a:p>
+        </p:txBody>
+      </p:sp>
+      <p:sp>
+        <p:nvSpPr>
+          <p:cNvPr id="11" name="Rounded Rectangle 10"/>
+          <p:cNvSpPr/>
+          <p:nvPr/>
+        </p:nvSpPr>
+        <p:spPr>
+          <a:xfrm>
+            <a:off x="365760" y="5852160"/>
+            <a:ext cx="8229600" cy="411480"/>
+          </a:xfrm>
+          <a:prstGeom prst="roundRect">
+            <a:avLst/>
+          </a:prstGeom>
+          <a:solidFill>
+            <a:srgbClr val="C05317"/>
+          </a:solidFill>
+          <a:ln>
+            <a:solidFill>
+              <a:srgbClr val="C05317"/>
+            </a:solidFill>
+          </a:ln>
+        </p:spPr>
+        <p:style>
+          <a:lnRef idx="1">
+            <a:schemeClr val="accent1"/>
+          </a:lnRef>
+          <a:fillRef idx="3">
+            <a:schemeClr val="accent1"/>
+          </a:fillRef>
+          <a:effectRef idx="2">
+            <a:schemeClr val="accent1"/>
+          </a:effectRef>
+          <a:fontRef idx="minor">
+            <a:schemeClr val="lt1"/>
+          </a:fontRef>
+        </p:style>
+        <p:txBody>
+          <a:bodyPr rtlCol="0" anchor="ctr"/>
+          <a:lstStyle/>
+          <a:p>
+            <a:pPr algn="ctr"/>
+            <a:r>
+              <a:rPr sz="1200" b="1">
+                <a:solidFill>
+                  <a:srgbClr val="FFFFFF"/>
                 </a:solidFill>
                 <a:latin typeface="Times New Roman"/>
               </a:rPr>
@@ -11382,30 +11839,6 @@
           </a:p>
         </p:txBody>
       </p:sp>
-      <p:pic>
-        <p:nvPicPr>
-          <p:cNvPr id="4" name="Picture 3" descr="hydrofoil_controller_flow.png"/>
-          <p:cNvPicPr>
-            <a:picLocks noChangeAspect="1"/>
-          </p:cNvPicPr>
-          <p:nvPr/>
-        </p:nvPicPr>
-        <p:blipFill>
-          <a:blip r:embed="rId2"/>
-          <a:stretch>
-            <a:fillRect/>
-          </a:stretch>
-        </p:blipFill>
-        <p:spPr>
-          <a:xfrm>
-            <a:off x="182880" y="868680"/>
-            <a:ext cx="8778240" cy="2926080"/>
-          </a:xfrm>
-          <a:prstGeom prst="rect">
-            <a:avLst/>
-          </a:prstGeom>
-        </p:spPr>
-      </p:pic>
       <p:sp>
         <p:nvSpPr>
           <p:cNvPr id="5" name="TextBox 4"/>
@@ -11575,6 +12008,30 @@
           </a:p>
         </p:txBody>
       </p:sp>
+      <p:pic>
+        <p:nvPicPr>
+          <p:cNvPr id="9" name="Picture 8" descr="hydrofoil_controller_flow.png"/>
+          <p:cNvPicPr>
+            <a:picLocks noChangeAspect="1"/>
+          </p:cNvPicPr>
+          <p:nvPr/>
+        </p:nvPicPr>
+        <p:blipFill>
+          <a:blip r:embed="rId3"/>
+          <a:stretch>
+            <a:fillRect/>
+          </a:stretch>
+        </p:blipFill>
+        <p:spPr>
+          <a:xfrm>
+            <a:off x="182880" y="868680"/>
+            <a:ext cx="8778240" cy="3108960"/>
+          </a:xfrm>
+          <a:prstGeom prst="rect">
+            <a:avLst/>
+          </a:prstGeom>
+        </p:spPr>
+      </p:pic>
     </p:spTree>
   </p:cSld>
   <p:clrMapOvr>
@@ -12260,6 +12717,263 @@
                 <a:latin typeface="Times New Roman"/>
               </a:rPr>
               <a:t>실용 의미: 추정 정확도가 느슨해도 FF는 동작 — 제어 성능의 nRMSE tolerance가 큼</a:t>
+            </a:r>
+          </a:p>
+        </p:txBody>
+      </p:sp>
+      <p:sp>
+        <p:nvSpPr>
+          <p:cNvPr id="6" name="TextBox 5"/>
+          <p:cNvSpPr txBox="1"/>
+          <p:nvPr/>
+        </p:nvSpPr>
+        <p:spPr>
+          <a:xfrm>
+            <a:off x="365760" y="4663440"/>
+            <a:ext cx="4114800" cy="274320"/>
+          </a:xfrm>
+          <a:prstGeom prst="rect">
+            <a:avLst/>
+          </a:prstGeom>
+          <a:noFill/>
+        </p:spPr>
+        <p:txBody>
+          <a:bodyPr wrap="none">
+            <a:spAutoFit/>
+          </a:bodyPr>
+          <a:lstStyle/>
+          <a:p>
+            <a:r>
+              <a:rPr sz="1200" b="1">
+                <a:solidFill>
+                  <a:srgbClr val="C05317"/>
+                </a:solidFill>
+                <a:latin typeface="Times New Roman"/>
+              </a:rPr>
+              <a:t>ISO 2631 승차감 기준 — 객관적 평가 척도</a:t>
+            </a:r>
+          </a:p>
+        </p:txBody>
+      </p:sp>
+      <p:sp>
+        <p:nvSpPr>
+          <p:cNvPr id="7" name="TextBox 6"/>
+          <p:cNvSpPr txBox="1"/>
+          <p:nvPr/>
+        </p:nvSpPr>
+        <p:spPr>
+          <a:xfrm>
+            <a:off x="365760" y="4983480"/>
+            <a:ext cx="4114800" cy="1554480"/>
+          </a:xfrm>
+          <a:prstGeom prst="rect">
+            <a:avLst/>
+          </a:prstGeom>
+          <a:noFill/>
+        </p:spPr>
+        <p:txBody>
+          <a:bodyPr wrap="square">
+            <a:spAutoFit/>
+          </a:bodyPr>
+          <a:lstStyle/>
+          <a:p>
+            <a:r>
+              <a:rPr sz="1000" b="0" i="0">
+                <a:solidFill>
+                  <a:srgbClr val="333333"/>
+                </a:solidFill>
+                <a:latin typeface="Times New Roman"/>
+              </a:rPr>
+              <a:t>▪ ISO 2631-1: 인체 vibration exposure 기준</a:t>
+            </a:r>
+          </a:p>
+          <a:p>
+            <a:r>
+              <a:rPr sz="1000" b="0" i="0">
+                <a:solidFill>
+                  <a:srgbClr val="333333"/>
+                </a:solidFill>
+                <a:latin typeface="Times New Roman"/>
+              </a:rPr>
+              <a:t>▪ aRMS [m/s²] 기준 분류:</a:t>
+            </a:r>
+          </a:p>
+          <a:p>
+            <a:r>
+              <a:rPr sz="1000" b="0" i="0">
+                <a:solidFill>
+                  <a:srgbClr val="333333"/>
+                </a:solidFill>
+                <a:latin typeface="Times New Roman"/>
+              </a:rPr>
+              <a:t>   &lt; 0.315  Comfortable</a:t>
+            </a:r>
+          </a:p>
+          <a:p>
+            <a:r>
+              <a:rPr sz="1000" b="0" i="0">
+                <a:solidFill>
+                  <a:srgbClr val="333333"/>
+                </a:solidFill>
+                <a:latin typeface="Times New Roman"/>
+              </a:rPr>
+              <a:t>   0.315 ~ 0.63  Slight discomfort</a:t>
+            </a:r>
+          </a:p>
+          <a:p>
+            <a:r>
+              <a:rPr sz="1000" b="0" i="0">
+                <a:solidFill>
+                  <a:srgbClr val="333333"/>
+                </a:solidFill>
+                <a:latin typeface="Times New Roman"/>
+              </a:rPr>
+              <a:t>   0.50 ~ 1.00  Fairly uncomfortable</a:t>
+            </a:r>
+          </a:p>
+          <a:p>
+            <a:r>
+              <a:rPr sz="1000" b="0" i="0">
+                <a:solidFill>
+                  <a:srgbClr val="333333"/>
+                </a:solidFill>
+                <a:latin typeface="Times New Roman"/>
+              </a:rPr>
+              <a:t>   0.80 ~ 1.60  Uncomfortable</a:t>
+            </a:r>
+          </a:p>
+          <a:p>
+            <a:r>
+              <a:rPr sz="1000" b="0" i="0">
+                <a:solidFill>
+                  <a:srgbClr val="333333"/>
+                </a:solidFill>
+                <a:latin typeface="Times New Roman"/>
+              </a:rPr>
+              <a:t>   &gt; 1.60  Very uncomfortable</a:t>
+            </a:r>
+          </a:p>
+        </p:txBody>
+      </p:sp>
+      <p:sp>
+        <p:nvSpPr>
+          <p:cNvPr id="8" name="TextBox 7"/>
+          <p:cNvSpPr txBox="1"/>
+          <p:nvPr/>
+        </p:nvSpPr>
+        <p:spPr>
+          <a:xfrm>
+            <a:off x="4663440" y="4663440"/>
+            <a:ext cx="3931920" cy="274320"/>
+          </a:xfrm>
+          <a:prstGeom prst="rect">
+            <a:avLst/>
+          </a:prstGeom>
+          <a:noFill/>
+        </p:spPr>
+        <p:txBody>
+          <a:bodyPr wrap="none">
+            <a:spAutoFit/>
+          </a:bodyPr>
+          <a:lstStyle/>
+          <a:p>
+            <a:r>
+              <a:rPr sz="1200" b="1">
+                <a:solidFill>
+                  <a:srgbClr val="C05317"/>
+                </a:solidFill>
+                <a:latin typeface="Times New Roman"/>
+              </a:rPr>
+              <a:t>Encounter angle 별 해석</a:t>
+            </a:r>
+          </a:p>
+        </p:txBody>
+      </p:sp>
+      <p:sp>
+        <p:nvSpPr>
+          <p:cNvPr id="9" name="TextBox 8"/>
+          <p:cNvSpPr txBox="1"/>
+          <p:nvPr/>
+        </p:nvSpPr>
+        <p:spPr>
+          <a:xfrm>
+            <a:off x="4663440" y="4983480"/>
+            <a:ext cx="3931920" cy="1554480"/>
+          </a:xfrm>
+          <a:prstGeom prst="rect">
+            <a:avLst/>
+          </a:prstGeom>
+          <a:noFill/>
+        </p:spPr>
+        <p:txBody>
+          <a:bodyPr wrap="square">
+            <a:spAutoFit/>
+          </a:bodyPr>
+          <a:lstStyle/>
+          <a:p>
+            <a:r>
+              <a:rPr sz="1000" b="0" i="0">
+                <a:solidFill>
+                  <a:srgbClr val="333333"/>
+                </a:solidFill>
+                <a:latin typeface="Times New Roman"/>
+              </a:rPr>
+              <a:t>▪ Head sea (μ=180°): 짧은 encounter wavelength →</a:t>
+            </a:r>
+          </a:p>
+          <a:p>
+            <a:r>
+              <a:rPr sz="1000" b="0" i="0">
+                <a:solidFill>
+                  <a:srgbClr val="333333"/>
+                </a:solidFill>
+                <a:latin typeface="Times New Roman"/>
+              </a:rPr>
+              <a:t>   Foil이 빠르게 wave 통과 → preview 짧아도 충분</a:t>
+            </a:r>
+          </a:p>
+          <a:p>
+            <a:r>
+              <a:rPr sz="1000" b="0" i="0">
+                <a:solidFill>
+                  <a:srgbClr val="333333"/>
+                </a:solidFill>
+                <a:latin typeface="Times New Roman"/>
+              </a:rPr>
+              <a:t>▪ Beam sea (μ=90°): 긴 encounter wavelength →</a:t>
+            </a:r>
+          </a:p>
+          <a:p>
+            <a:r>
+              <a:rPr sz="1000" b="0" i="0">
+                <a:solidFill>
+                  <a:srgbClr val="333333"/>
+                </a:solidFill>
+                <a:latin typeface="Times New Roman"/>
+              </a:rPr>
+              <a:t>   파면이 천천히 변화 → preview 길어야 효과적</a:t>
+            </a:r>
+          </a:p>
+          <a:p>
+            <a:r>
+              <a:rPr sz="1000" b="0" i="0">
+                <a:solidFill>
+                  <a:srgbClr val="333333"/>
+                </a:solidFill>
+                <a:latin typeface="Times New Roman"/>
+              </a:rPr>
+              <a:t>▪ Quarter (μ=135°): 중간 — 균형적</a:t>
+            </a:r>
+          </a:p>
+          <a:p>
+            <a:r>
+              <a:rPr sz="1000" b="0" i="0">
+                <a:solidFill>
+                  <a:srgbClr val="333333"/>
+                </a:solidFill>
+                <a:latin typeface="Times New Roman"/>
+              </a:rPr>
+              <a:t>▪ Following (μ=0°): 거의 정적 → FF 효과 적음 (생략)</a:t>
             </a:r>
           </a:p>
         </p:txBody>
@@ -13174,22 +13888,123 @@
       </p:sp>
       <p:sp>
         <p:nvSpPr>
-          <p:cNvPr id="7" name="Rectangle 6"/>
-          <p:cNvSpPr/>
+          <p:cNvPr id="7" name="TextBox 6"/>
+          <p:cNvSpPr txBox="1"/>
           <p:nvPr/>
         </p:nvSpPr>
         <p:spPr>
           <a:xfrm>
-            <a:off x="365760" y="5897880"/>
-            <a:ext cx="8229600" cy="320040"/>
+            <a:off x="365760" y="4846320"/>
+            <a:ext cx="8229600" cy="274320"/>
           </a:xfrm>
           <a:prstGeom prst="rect">
             <a:avLst/>
           </a:prstGeom>
+          <a:noFill/>
+        </p:spPr>
+        <p:txBody>
+          <a:bodyPr wrap="none">
+            <a:spAutoFit/>
+          </a:bodyPr>
+          <a:lstStyle/>
+          <a:p>
+            <a:r>
+              <a:rPr sz="1200" b="1">
+                <a:solidFill>
+                  <a:srgbClr val="C05317"/>
+                </a:solidFill>
+                <a:latin typeface="Times New Roman"/>
+              </a:rPr>
+              <a:t>BF4 한계의 원인 — Direction error 전파</a:t>
+            </a:r>
+          </a:p>
+        </p:txBody>
+      </p:sp>
+      <p:sp>
+        <p:nvSpPr>
+          <p:cNvPr id="8" name="TextBox 7"/>
+          <p:cNvSpPr txBox="1"/>
+          <p:nvPr/>
+        </p:nvSpPr>
+        <p:spPr>
+          <a:xfrm>
+            <a:off x="365760" y="5166360"/>
+            <a:ext cx="8229600" cy="1188720"/>
+          </a:xfrm>
+          <a:prstGeom prst="rect">
+            <a:avLst/>
+          </a:prstGeom>
+          <a:noFill/>
+        </p:spPr>
+        <p:txBody>
+          <a:bodyPr wrap="square">
+            <a:spAutoFit/>
+          </a:bodyPr>
+          <a:lstStyle/>
+          <a:p>
+            <a:r>
+              <a:rPr sz="1100" b="0" i="0">
+                <a:solidFill>
+                  <a:srgbClr val="333333"/>
+                </a:solidFill>
+                <a:latin typeface="Times New Roman"/>
+              </a:rPr>
+              <a:t>▪ FF 명령 = K_ff × α_wave   ←   α_wave = −∂η/∂x − w/V</a:t>
+            </a:r>
+          </a:p>
+          <a:p>
+            <a:r>
+              <a:rPr sz="1100" b="0" i="0">
+                <a:solidFill>
+                  <a:srgbClr val="333333"/>
+                </a:solidFill>
+                <a:latin typeface="Times New Roman"/>
+              </a:rPr>
+              <a:t>▪ ∂η/∂x는 wave 방향 미분 → direction estimate에 supersensitive</a:t>
+            </a:r>
+          </a:p>
+          <a:p>
+            <a:r>
+              <a:rPr sz="1100" b="0" i="0">
+                <a:solidFill>
+                  <a:srgbClr val="333333"/>
+                </a:solidFill>
+                <a:latin typeface="Times New Roman"/>
+              </a:rPr>
+              <a:t>▪ Direction이 5° 어긋나면 ∂η/∂x 부호 바뀔 수 있음 → FF가 오히려 disturbance 증폭</a:t>
+            </a:r>
+          </a:p>
+          <a:p>
+            <a:r>
+              <a:rPr sz="1100" b="0" i="0">
+                <a:solidFill>
+                  <a:srgbClr val="333333"/>
+                </a:solidFill>
+                <a:latin typeface="Times New Roman"/>
+              </a:rPr>
+              <a:t>▪ BF4 5-comp 사례: 두 component가 ±20° 분리되어 있어 superposition 시 phase 어긋남</a:t>
+            </a:r>
+          </a:p>
+        </p:txBody>
+      </p:sp>
+      <p:sp>
+        <p:nvSpPr>
+          <p:cNvPr id="9" name="Rounded Rectangle 8"/>
+          <p:cNvSpPr/>
+          <p:nvPr/>
+        </p:nvSpPr>
+        <p:spPr>
+          <a:xfrm>
+            <a:off x="365760" y="5989320"/>
+            <a:ext cx="8229600" cy="365760"/>
+          </a:xfrm>
+          <a:prstGeom prst="roundRect">
+            <a:avLst/>
+          </a:prstGeom>
           <a:solidFill>
-            <a:srgbClr val="FFF7ED"/>
+            <a:srgbClr val="C05317"/>
           </a:solidFill>
-          <a:ln w="19050">
+          <a:ln>
             <a:solidFill>
               <a:srgbClr val="C05317"/>
             </a:solidFill>
@@ -13210,19 +14025,18 @@
           </a:fontRef>
         </p:style>
         <p:txBody>
-          <a:bodyPr rtlCol="0" anchor="ctr" wrap="square"/>
+          <a:bodyPr rtlCol="0" anchor="ctr"/>
           <a:lstStyle/>
           <a:p>
             <a:pPr algn="ctr"/>
             <a:r>
-              <a:rPr sz="1000" i="1">
-                <a:solidFill>
-                  <a:srgbClr val="C05317"/>
-                </a:solidFill>
-                <a:latin typeface="Times New Roman"/>
-              </a:rPr>
-              <a:t>[ 그림 자리 ]
-thesis/figures_hf/fig_e2e_timeseries.pdf — heave &amp; pitch 시계열 (선택)</a:t>
+              <a:rPr sz="1100" b="1">
+                <a:solidFill>
+                  <a:srgbClr val="FFFFFF"/>
+                </a:solidFill>
+                <a:latin typeface="Times New Roman"/>
+              </a:rPr>
+              <a:t>개선 방향: (a) vessel yaw 변화 활용한 multi-frame direction voting  (b) IMU heading 기반 directional prior</a:t>
             </a:r>
           </a:p>
         </p:txBody>

</xml_diff>

<commit_message>
PPT v2.3: Dir R² metric 책임전가 framing 제거 (Slide 28/29)
이전 commit 에서 Dir R² 를 "보조 지표"로 demote 했지만, 두 슬라이드에 잔존:
- Slide 28 (Hydrofoil E2E): "보조 지표 directional spectrum 의 한계가 제어로 전파"
- Slide 29 (Limitations): "Directional spectrum (보조 지표): 30+ comp 에서 R² 폭발
   (peak alignment 민감도 — metric 자체의 한계)"

→ 두 곳 모두 metric 책임전가 framing 대신 알고리즘 자체의 한계로 재서술:

Slide 28:
- "BF4 5-comp: 37% — directional misestimation 의 영향"
  → "BF4 5-comp: 37% — 다중 component 간 방향 분리 한계가 원인"
- "보조 지표 directional spectrum 의 한계가 제어로 전파됨"
  → "WaveSplat 의 방향 추정 오차(±5° 이상)가 그대로 제어 입력으로 전파됨"

Slide 29:
- "Directional spectrum (보조 지표): 30+ comp 에서 R² 폭발 (peak alignment
   민감도 — metric 자체의 한계)"
  → "30+ component crowding 시 방향 분리 어려움 (k-space 에서 인접 peak)
     → multi-frame 방향 voting / vessel yaw 변화 활용으로 개선 가능"

이제 limitation 을 솔직하게 알고리즘 측 (beamforming spatial resolution +
directional 분리력) 의 한계로 표현 — metric 핑계 X.

Co-Authored-By: Claude Opus 4.7 (1M context) <noreply@anthropic.com>
</commit_message>
<xml_diff>
--- a/wavesplat/docs/labmeeting_wavesplat.pptx
+++ b/wavesplat/docs/labmeeting_wavesplat.pptx
@@ -14435,7 +14435,7 @@
                 </a:solidFill>
                 <a:latin typeface="Times New Roman"/>
               </a:rPr>
-              <a:t>▪ BF4 5-comp: 37% — directional misestimation의 영향</a:t>
+              <a:t>▪ BF4 5-comp: 37% — 다중 component 간 방향 분리 한계가 원인</a:t>
             </a:r>
           </a:p>
           <a:p>
@@ -14446,7 +14446,7 @@
                 </a:solidFill>
                 <a:latin typeface="Times New Roman"/>
               </a:rPr>
-              <a:t>   → 보조 지표 directional spectrum의 한계가 제어로 전파됨</a:t>
+              <a:t>   → WaveSplat의 방향 추정 오차(±5° 이상)가 그대로 제어 입력으로 전파됨</a:t>
             </a:r>
           </a:p>
           <a:p>
@@ -14795,7 +14795,7 @@
                 </a:solidFill>
                 <a:latin typeface="Times New Roman"/>
               </a:rPr>
-              <a:t>▪ Directional spectrum (보조 지표): 30+ comp에서 R² 폭발</a:t>
+              <a:t>▪ 30+ component crowding 시 방향 분리 어려움 (k-space에서 인접 peak)</a:t>
             </a:r>
           </a:p>
           <a:p>
@@ -14806,7 +14806,7 @@
                 </a:solidFill>
                 <a:latin typeface="Times New Roman"/>
               </a:rPr>
-              <a:t>   (peak alignment 민감도 — metric 자체의 한계)</a:t>
+              <a:t>   → multi-frame 방향 voting / vessel yaw 변화 활용으로 개선 가능</a:t>
             </a:r>
           </a:p>
           <a:p>

</xml_diff>